<commit_message>
Update Presentación Limitaciones Experimentos.pptx
</commit_message>
<xml_diff>
--- a/Presentación Limitaciones Experimentos.pptx
+++ b/Presentación Limitaciones Experimentos.pptx
@@ -1323,44 +1323,6 @@
             <a:pPr marL="0" indent="0">
               <a:buNone/>
             </a:pPr>
-            <a:r>
-              <a:rPr lang="en-US" sz="1300" b="1" i="1" dirty="0">
-                <a:solidFill>
-                  <a:srgbClr val="1E2761"/>
-                </a:solidFill>
-                <a:latin typeface="Calibri" pitchFamily="34" charset="0"/>
-                <a:ea typeface="Calibri" pitchFamily="34" charset="-122"/>
-                <a:cs typeface="Calibri" pitchFamily="34" charset="-120"/>
-              </a:rPr>
-              <a:t>Conocer las limitaciones no invalida el experimento — cambia cómo interpretamos sus </a:t>
-            </a:r>
-            <a:r>
-              <a:rPr lang="en-US" sz="1300" b="1" i="1" dirty="0" err="1">
-                <a:solidFill>
-                  <a:srgbClr val="1E2761"/>
-                </a:solidFill>
-                <a:latin typeface="Calibri" pitchFamily="34" charset="0"/>
-                <a:ea typeface="Calibri" pitchFamily="34" charset="-122"/>
-                <a:cs typeface="Calibri" pitchFamily="34" charset="-120"/>
-              </a:rPr>
-              <a:t>resultados</a:t>
-            </a:r>
-            <a:r>
-              <a:rPr lang="en-US" sz="1300" b="1" i="1" dirty="0">
-                <a:solidFill>
-                  <a:srgbClr val="1E2761"/>
-                </a:solidFill>
-                <a:latin typeface="Calibri" pitchFamily="34" charset="0"/>
-                <a:ea typeface="Calibri" pitchFamily="34" charset="-122"/>
-                <a:cs typeface="Calibri" pitchFamily="34" charset="-120"/>
-              </a:rPr>
-              <a:t>.</a:t>
-            </a:r>
-          </a:p>
-          <a:p>
-            <a:pPr marL="0" indent="0">
-              <a:buNone/>
-            </a:pPr>
             <a:endParaRPr lang="en-US" sz="1300" b="1" i="1" dirty="0">
               <a:solidFill>
                 <a:srgbClr val="1E2761"/>
@@ -1376,7 +1338,15 @@
             </a:pPr>
             <a:r>
               <a:rPr lang="es-ES" sz="1300" dirty="0"/>
-              <a:t>Para validar los experimentos en el mundo real es importante conocer:</a:t>
+              <a:t>Para </a:t>
+            </a:r>
+            <a:r>
+              <a:rPr lang="es-ES" sz="1300" b="1" dirty="0"/>
+              <a:t>validar los experimentos en el mundo real </a:t>
+            </a:r>
+            <a:r>
+              <a:rPr lang="es-ES" sz="1300" dirty="0"/>
+              <a:t>es importante conocer:</a:t>
             </a:r>
           </a:p>
           <a:p>

</xml_diff>